<commit_message>
Merge tabs into Overview/Feeders/Respond, add live AI summary, stop inventing weather values
Co-Authored-By: Claude Sonnet 5.5 <noreply@anthropic.com>
</commit_message>
<xml_diff>
--- a/docs/SurgeGrid_AI_Deck.pptx
+++ b/docs/SurgeGrid_AI_Deck.pptx
@@ -11894,7 +11894,7 @@
                 <a:latin typeface="Segoe UI"/>
               </a:rPr>
               <a:t>Picks substation and feeder names from lists we send.
-Writes one short note.
+Writes one short note, or a live-day summary of our data.
 Gemini 2.5 Flash on Google Cloud, no API key in the app.</a:t>
             </a:r>
           </a:p>
@@ -13345,7 +13345,7 @@
                 </a:solidFill>
                 <a:latin typeface="Segoe UI"/>
               </a:rPr>
-              <a:t>Open a low-lying substation: status line, then Crisis &amp; Contacts: copilot actions, flood facts, official flood maps, relief centre, backup.</a:t>
+              <a:t>Open a low-lying substation: status line, Overview (flood facts, official maps), then Respond: copilot actions, relief centre, backup.</a:t>
             </a:r>
           </a:p>
         </p:txBody>

</xml_diff>

<commit_message>
Docs: one-event build (Michaung, five steps, rain by cell, exposed list); IMD bulletin source; deck text, video script, README, feature map, architecture doc, llms files and page description updated; project log items 44 to 52
Co-Authored-By: Claude Sonnet 5.5 <noreply@anthropic.com>
</commit_message>
<xml_diff>
--- a/docs/SurgeGrid_AI_Deck.pptx
+++ b/docs/SurgeGrid_AI_Deck.pptx
@@ -1073,7 +1073,7 @@
           <a:lstStyle/>
           <a:p>
             <a:r>
-              <a:t>We deleted our earlier synthetic cyclone. Everything replayed is real rain and wind.</a:t>
+              <a:t>We deleted our earlier synthetic cyclone and two other events to focus on one real storm. Everything replayed is real rain and wind. Rain classes are IMD's, applied to a rolling 24-hour total over about 11 km cells. We do not draw flood water: none of our flood data has a time in it.</a:t>
             </a:r>
           </a:p>
         </p:txBody>
@@ -6791,7 +6791,7 @@
                 </a:solidFill>
                 <a:latin typeface="Segoe UI"/>
               </a:rPr>
-              <a:t>More cities. Substations ranked by homes in mapped flood areas. Hospital and shelter exposure. Tamil advisories. Faster mobile load.</a:t>
+              <a:t>More storms and cities. Substations ranked by homes in mapped flood areas. Hospital and shelter exposure. Finer rain data. Tamil advisories. Faster mobile load.</a:t>
             </a:r>
           </a:p>
         </p:txBody>
@@ -8741,7 +8741,7 @@
                 </a:solidFill>
                 <a:latin typeface="Segoe UI"/>
               </a:rPr>
-              <a:t>Three real rain events, hour by hour: Michaung 2023, the 2015 floods, a Nov 2020 monsoon spell.</a:t>
+              <a:t>Cyclone Michaung in five steps: two before the peak, the peak, two after. Rain by area on the map.</a:t>
             </a:r>
           </a:p>
         </p:txBody>
@@ -8911,7 +8911,7 @@
                 </a:solidFill>
                 <a:latin typeface="Segoe UI"/>
               </a:rPr>
-              <a:t>286 substations with yard elevation and checks against official flood maps.</a:t>
+              <a:t>286 substations: yard elevation, official flood maps, and an exposed-now list at each step.</a:t>
             </a:r>
           </a:p>
         </p:txBody>
@@ -10850,7 +10850,7 @@
                           </a:solidFill>
                           <a:latin typeface="Segoe UI Semibold"/>
                         </a:rPr>
-                        <a:t>Scenario</a:t>
+                        <a:t>Michaung, Dec 2023</a:t>
                       </a:r>
                     </a:p>
                   </a:txBody>
@@ -10873,7 +10873,7 @@
                           </a:solidFill>
                           <a:latin typeface="Segoe UI Semibold"/>
                         </a:rPr>
-                        <a:t>Peak rain</a:t>
+                        <a:t>Area mean</a:t>
                       </a:r>
                     </a:p>
                   </a:txBody>
@@ -10896,7 +10896,7 @@
                           </a:solidFill>
                           <a:latin typeface="Segoe UI Semibold"/>
                         </a:rPr>
-                        <a:t>Total rain</a:t>
+                        <a:t>Across 28 rain cells</a:t>
                       </a:r>
                     </a:p>
                   </a:txBody>
@@ -10921,7 +10921,7 @@
                           </a:solidFill>
                           <a:latin typeface="Segoe UI"/>
                         </a:rPr>
-                        <a:t>Cyclone Michaung, Dec 2023</a:t>
+                        <a:t>Peak rain</a:t>
                       </a:r>
                     </a:p>
                   </a:txBody>
@@ -10967,7 +10967,7 @@
                           </a:solidFill>
                           <a:latin typeface="Segoe UI"/>
                         </a:rPr>
-                        <a:t>273 mm</a:t>
+                        <a:t>7.6 to 21.1 mm/h</a:t>
                       </a:r>
                     </a:p>
                   </a:txBody>
@@ -10992,7 +10992,7 @@
                           </a:solidFill>
                           <a:latin typeface="Segoe UI"/>
                         </a:rPr>
-                        <a:t>2015 floods</a:t>
+                        <a:t>Total rain</a:t>
                       </a:r>
                     </a:p>
                   </a:txBody>
@@ -11015,7 +11015,7 @@
                           </a:solidFill>
                           <a:latin typeface="Segoe UI"/>
                         </a:rPr>
-                        <a:t>23.4 mm/h</a:t>
+                        <a:t>273 mm</a:t>
                       </a:r>
                     </a:p>
                   </a:txBody>
@@ -11038,7 +11038,7 @@
                           </a:solidFill>
                           <a:latin typeface="Segoe UI"/>
                         </a:rPr>
-                        <a:t>372 mm</a:t>
+                        <a:t>219 to 319 mm</a:t>
                       </a:r>
                     </a:p>
                   </a:txBody>
@@ -11063,7 +11063,7 @@
                           </a:solidFill>
                           <a:latin typeface="Segoe UI"/>
                         </a:rPr>
-                        <a:t>Monsoon spell, Nov 2020</a:t>
+                        <a:t>Worst 24 hours</a:t>
                       </a:r>
                     </a:p>
                   </a:txBody>
@@ -11086,7 +11086,7 @@
                           </a:solidFill>
                           <a:latin typeface="Segoe UI"/>
                         </a:rPr>
-                        <a:t>16.8 mm/h</a:t>
+                        <a:t>200 mm</a:t>
                       </a:r>
                     </a:p>
                   </a:txBody>
@@ -11109,7 +11109,7 @@
                           </a:solidFill>
                           <a:latin typeface="Segoe UI"/>
                         </a:rPr>
-                        <a:t>198 mm</a:t>
+                        <a:t>144 to 253 mm</a:t>
                       </a:r>
                     </a:p>
                   </a:txBody>
@@ -13005,7 +13005,7 @@
                 </a:solidFill>
                 <a:latin typeface="Segoe UI"/>
               </a:rPr>
-              <a:t>Open the site. Michaung starts at T-24h. The AI Directive shows 6 quoted actions with page numbers.</a:t>
+              <a:t>Open the site, pick Michaung. It starts at T-24h with the rain layer nearly clear. The AI Directive shows 6 quoted actions with page numbers.</a:t>
             </a:r>
           </a:p>
         </p:txBody>
@@ -13175,7 +13175,7 @@
                 </a:solidFill>
                 <a:latin typeface="Segoe UI"/>
               </a:rPr>
-              <a:t>Press play at 4x. The directive moves to impact, then restoration.</a:t>
+              <a:t>Press play: five steps, 6 seconds each. Rain fills in by cell, exposed substations get red rings, and the Exposed now list grows from 0 to 87.</a:t>
             </a:r>
           </a:p>
         </p:txBody>
@@ -13345,7 +13345,7 @@
                 </a:solidFill>
                 <a:latin typeface="Segoe UI"/>
               </a:rPr>
-              <a:t>Open a low-lying substation: status line, Overview (flood facts, official maps), then Respond: copilot actions, relief centre, backup.</a:t>
+              <a:t>Point at a cell for its 24-hour rain and IMD class. Switch on the fixed official flood maps.</a:t>
             </a:r>
           </a:p>
         </p:txBody>
@@ -13515,7 +13515,7 @@
                 </a:solidFill>
                 <a:latin typeface="Segoe UI"/>
               </a:rPr>
-              <a:t>Open a substation inside no flood layer. It stays quiet: no false alarms.</a:t>
+              <a:t>Open a low-lying substation: status line, Overview (flood facts), then Respond: copilot actions, relief centre, backup.</a:t>
             </a:r>
           </a:p>
         </p:txBody>
@@ -13685,7 +13685,7 @@
                 </a:solidFill>
                 <a:latin typeface="Segoe UI"/>
               </a:rPr>
-              <a:t>Switch to the 2015 scenario. Turn on the relief-centre layer.</a:t>
+              <a:t>Open a substation inside no flood layer. It stays quiet: no false alarms.</a:t>
             </a:r>
           </a:p>
         </p:txBody>
@@ -14110,7 +14110,7 @@
                           </a:solidFill>
                           <a:latin typeface="Segoe UI"/>
                         </a:rPr>
-                        <a:t>Three real hindcasts, hour by hour</a:t>
+                        <a:t>One real hindcast (Michaung), five steps, rain by area</a:t>
                       </a:r>
                     </a:p>
                   </a:txBody>
@@ -14132,7 +14132,7 @@
                           </a:solidFill>
                           <a:latin typeface="Segoe UI"/>
                         </a:rPr>
-                        <a:t>No storm surge or track</a:t>
+                        <a:t>No storm surge or track; no flood prediction</a:t>
                       </a:r>
                     </a:p>
                   </a:txBody>

</xml_diff>

<commit_message>
Docs: satellite rain reads below IMD's gauges (3 and 4 Dec bulletins), early-step claims corrected, IMD at the time and landfall alignment, deck slides 6 and 8, project log item 53
Co-Authored-By: Claude Sonnet 5.5 <noreply@anthropic.com>
</commit_message>
<xml_diff>
--- a/docs/SurgeGrid_AI_Deck.pptx
+++ b/docs/SurgeGrid_AI_Deck.pptx
@@ -1073,7 +1073,7 @@
           <a:lstStyle/>
           <a:p>
             <a:r>
-              <a:t>We deleted our earlier synthetic cyclone and two other events to focus on one real storm. Everything replayed is real rain and wind. Rain classes are IMD's, applied to a rolling 24-hour total over about 11 km cells. We do not draw flood water: none of our flood data has a time in it.</a:t>
+              <a:t>We show that our satellite rain reads below IMD's own rain gauges (Chennai district: 16 stations listed 70 to 100 mm on 3 Dec, 50 stations listed 70 to 290 mm on 4 Dec) and we do not scale it up. The early steps therefore look quieter than the gauges say, and the early exposed counts are probably too low. We deleted our earlier synthetic cyclone and two other events to focus on one real storm.</a:t>
             </a:r>
           </a:p>
         </p:txBody>
@@ -10873,7 +10873,7 @@
                           </a:solidFill>
                           <a:latin typeface="Segoe UI Semibold"/>
                         </a:rPr>
-                        <a:t>Area mean</a:t>
+                        <a:t>Satellite cells</a:t>
                       </a:r>
                     </a:p>
                   </a:txBody>
@@ -10896,7 +10896,7 @@
                           </a:solidFill>
                           <a:latin typeface="Segoe UI Semibold"/>
                         </a:rPr>
-                        <a:t>Across 28 rain cells</a:t>
+                        <a:t>IMD gauges</a:t>
                       </a:r>
                     </a:p>
                   </a:txBody>
@@ -10921,7 +10921,7 @@
                           </a:solidFill>
                           <a:latin typeface="Segoe UI"/>
                         </a:rPr>
-                        <a:t>Peak rain</a:t>
+                        <a:t>Rain to 08:30 IST 3 Dec</a:t>
                       </a:r>
                     </a:p>
                   </a:txBody>
@@ -10944,7 +10944,7 @@
                           </a:solidFill>
                           <a:latin typeface="Segoe UI"/>
                         </a:rPr>
-                        <a:t>14.0 mm/h</a:t>
+                        <a:t>13 to 37 mm</a:t>
                       </a:r>
                     </a:p>
                   </a:txBody>
@@ -10967,7 +10967,7 @@
                           </a:solidFill>
                           <a:latin typeface="Segoe UI"/>
                         </a:rPr>
-                        <a:t>7.6 to 21.1 mm/h</a:t>
+                        <a:t>70 to 100 mm</a:t>
                       </a:r>
                     </a:p>
                   </a:txBody>
@@ -10992,7 +10992,78 @@
                           </a:solidFill>
                           <a:latin typeface="Segoe UI"/>
                         </a:rPr>
-                        <a:t>Total rain</a:t>
+                        <a:t>Rain to 08:30 IST 4 Dec</a:t>
+                      </a:r>
+                    </a:p>
+                  </a:txBody>
+                  <a:tcPr anchor="ctr" marL="182880">
+                    <a:solidFill>
+                      <a:srgbClr val="131D33"/>
+                    </a:solidFill>
+                  </a:tcPr>
+                </a:tc>
+                <a:tc>
+                  <a:txBody>
+                    <a:bodyPr/>
+                    <a:lstStyle/>
+                    <a:p>
+                      <a:pPr algn="r"/>
+                      <a:r>
+                        <a:rPr sz="1600">
+                          <a:solidFill>
+                            <a:srgbClr val="2DD4BF"/>
+                          </a:solidFill>
+                          <a:latin typeface="Segoe UI"/>
+                        </a:rPr>
+                        <a:t>106 to 184 mm</a:t>
+                      </a:r>
+                    </a:p>
+                  </a:txBody>
+                  <a:tcPr anchor="ctr" marL="182880">
+                    <a:solidFill>
+                      <a:srgbClr val="131D33"/>
+                    </a:solidFill>
+                  </a:tcPr>
+                </a:tc>
+                <a:tc>
+                  <a:txBody>
+                    <a:bodyPr/>
+                    <a:lstStyle/>
+                    <a:p>
+                      <a:pPr algn="r"/>
+                      <a:r>
+                        <a:rPr sz="1600">
+                          <a:solidFill>
+                            <a:srgbClr val="2DD4BF"/>
+                          </a:solidFill>
+                          <a:latin typeface="Segoe UI"/>
+                        </a:rPr>
+                        <a:t>70 to 290 mm</a:t>
+                      </a:r>
+                    </a:p>
+                  </a:txBody>
+                  <a:tcPr anchor="ctr" marL="182880">
+                    <a:solidFill>
+                      <a:srgbClr val="131D33"/>
+                    </a:solidFill>
+                  </a:tcPr>
+                </a:tc>
+              </a:tr>
+              <a:tr h="548640">
+                <a:tc>
+                  <a:txBody>
+                    <a:bodyPr/>
+                    <a:lstStyle/>
+                    <a:p>
+                      <a:pPr algn="l"/>
+                      <a:r>
+                        <a:rPr sz="1600">
+                          <a:solidFill>
+                            <a:srgbClr val="F1F5F9"/>
+                          </a:solidFill>
+                          <a:latin typeface="Segoe UI"/>
+                        </a:rPr>
+                        <a:t>Whole event, mean</a:t>
                       </a:r>
                     </a:p>
                   </a:txBody>
@@ -11038,78 +11109,7 @@
                           </a:solidFill>
                           <a:latin typeface="Segoe UI"/>
                         </a:rPr>
-                        <a:t>219 to 319 mm</a:t>
-                      </a:r>
-                    </a:p>
-                  </a:txBody>
-                  <a:tcPr anchor="ctr" marL="182880">
-                    <a:solidFill>
-                      <a:srgbClr val="131D33"/>
-                    </a:solidFill>
-                  </a:tcPr>
-                </a:tc>
-              </a:tr>
-              <a:tr h="548640">
-                <a:tc>
-                  <a:txBody>
-                    <a:bodyPr/>
-                    <a:lstStyle/>
-                    <a:p>
-                      <a:pPr algn="l"/>
-                      <a:r>
-                        <a:rPr sz="1600">
-                          <a:solidFill>
-                            <a:srgbClr val="F1F5F9"/>
-                          </a:solidFill>
-                          <a:latin typeface="Segoe UI"/>
-                        </a:rPr>
-                        <a:t>Worst 24 hours</a:t>
-                      </a:r>
-                    </a:p>
-                  </a:txBody>
-                  <a:tcPr anchor="ctr" marL="182880">
-                    <a:solidFill>
-                      <a:srgbClr val="131D33"/>
-                    </a:solidFill>
-                  </a:tcPr>
-                </a:tc>
-                <a:tc>
-                  <a:txBody>
-                    <a:bodyPr/>
-                    <a:lstStyle/>
-                    <a:p>
-                      <a:pPr algn="r"/>
-                      <a:r>
-                        <a:rPr sz="1600">
-                          <a:solidFill>
-                            <a:srgbClr val="2DD4BF"/>
-                          </a:solidFill>
-                          <a:latin typeface="Segoe UI"/>
-                        </a:rPr>
-                        <a:t>200 mm</a:t>
-                      </a:r>
-                    </a:p>
-                  </a:txBody>
-                  <a:tcPr anchor="ctr" marL="182880">
-                    <a:solidFill>
-                      <a:srgbClr val="131D33"/>
-                    </a:solidFill>
-                  </a:tcPr>
-                </a:tc>
-                <a:tc>
-                  <a:txBody>
-                    <a:bodyPr/>
-                    <a:lstStyle/>
-                    <a:p>
-                      <a:pPr algn="r"/>
-                      <a:r>
-                        <a:rPr sz="1600">
-                          <a:solidFill>
-                            <a:srgbClr val="2DD4BF"/>
-                          </a:solidFill>
-                          <a:latin typeface="Segoe UI"/>
-                        </a:rPr>
-                        <a:t>144 to 253 mm</a:t>
+                        <a:t>not reported</a:t>
                       </a:r>
                     </a:p>
                   </a:txBody>
@@ -13005,7 +13005,7 @@
                 </a:solidFill>
                 <a:latin typeface="Segoe UI"/>
               </a:rPr>
-              <a:t>Open the site, pick Michaung. It starts at T-24h with the rain layer nearly clear. The AI Directive shows 6 quoted actions with page numbers.</a:t>
+              <a:t>Open the site, pick Michaung. It starts at T-24h. The satellite rain is nearly clear (IMD's gauges read higher). The AI Directive shows 6 quoted actions with page numbers.</a:t>
             </a:r>
           </a:p>
         </p:txBody>
@@ -13175,7 +13175,7 @@
                 </a:solidFill>
                 <a:latin typeface="Segoe UI"/>
               </a:rPr>
-              <a:t>Press play: five steps, 6 seconds each. Rain fills in by cell, exposed substations get red rings, and the Exposed now list grows from 0 to 87.</a:t>
+              <a:t>Press play: five steps, 6 seconds each. Rain fills in by cell, exposed substations get red rings, and IMD's own bulletin for each step is quoted under the timeline.</a:t>
             </a:r>
           </a:p>
         </p:txBody>

</xml_diff>

<commit_message>
Docs: station-level satellite-versus-gauge check (IMD final report and the Tamil Nadu gauge list), observed best track and Chennai wind, SOURCES entries, deck slide 6, script, project log item 54
Co-Authored-By: Claude Sonnet 5.5 <noreply@anthropic.com>
</commit_message>
<xml_diff>
--- a/docs/SurgeGrid_AI_Deck.pptx
+++ b/docs/SurgeGrid_AI_Deck.pptx
@@ -1073,7 +1073,7 @@
           <a:lstStyle/>
           <a:p>
             <a:r>
-              <a:t>We show that our satellite rain reads below IMD's own rain gauges (Chennai district: 16 stations listed 70 to 100 mm on 3 Dec, 50 stations listed 70 to 290 mm on 4 Dec) and we do not scale it up. The early steps therefore look quieter than the gauges say, and the early exposed counts are probably too low. We deleted our earlier synthetic cyclone and two other events to focus on one real storm.</a:t>
+              <a:t>We checked our satellite rain station by station against IMD's own gauges (17 gauges matched by exact name, coordinates from the Tamil Nadu gauge list; 7, 16 and 9 stations on 3, 4 and 5 Dec). The satellite cell held about a third of the gauge total on 3 Dec and two-thirds to three-quarters after, so the early steps look quieter than the gauges say. We show that and do not scale it up. Our wind (37 km/h) is also below IMD's Chennai stations (56 to 68 km/h, gusts 75 to 90). We deleted our earlier synthetic cyclone and two other events to focus on one real storm.</a:t>
             </a:r>
           </a:p>
         </p:txBody>
@@ -10850,7 +10850,7 @@
                           </a:solidFill>
                           <a:latin typeface="Segoe UI Semibold"/>
                         </a:rPr>
-                        <a:t>Michaung, Dec 2023</a:t>
+                        <a:t>Michaung, Dec 2023 (medians)</a:t>
                       </a:r>
                     </a:p>
                   </a:txBody>
@@ -10873,7 +10873,7 @@
                           </a:solidFill>
                           <a:latin typeface="Segoe UI Semibold"/>
                         </a:rPr>
-                        <a:t>Satellite cells</a:t>
+                        <a:t>Satellite cell</a:t>
                       </a:r>
                     </a:p>
                   </a:txBody>
@@ -10896,7 +10896,7 @@
                           </a:solidFill>
                           <a:latin typeface="Segoe UI Semibold"/>
                         </a:rPr>
-                        <a:t>IMD gauges</a:t>
+                        <a:t>IMD gauge</a:t>
                       </a:r>
                     </a:p>
                   </a:txBody>
@@ -10921,7 +10921,7 @@
                           </a:solidFill>
                           <a:latin typeface="Segoe UI"/>
                         </a:rPr>
-                        <a:t>Rain to 08:30 IST 3 Dec</a:t>
+                        <a:t>24 h to 08:30 IST, 3 Dec</a:t>
                       </a:r>
                     </a:p>
                   </a:txBody>
@@ -10944,7 +10944,7 @@
                           </a:solidFill>
                           <a:latin typeface="Segoe UI"/>
                         </a:rPr>
-                        <a:t>13 to 37 mm</a:t>
+                        <a:t>30 mm</a:t>
                       </a:r>
                     </a:p>
                   </a:txBody>
@@ -10967,7 +10967,7 @@
                           </a:solidFill>
                           <a:latin typeface="Segoe UI"/>
                         </a:rPr>
-                        <a:t>70 to 100 mm</a:t>
+                        <a:t>80 mm</a:t>
                       </a:r>
                     </a:p>
                   </a:txBody>
@@ -10992,7 +10992,7 @@
                           </a:solidFill>
                           <a:latin typeface="Segoe UI"/>
                         </a:rPr>
-                        <a:t>Rain to 08:30 IST 4 Dec</a:t>
+                        <a:t>24 h to 08:30 IST, 4 Dec</a:t>
                       </a:r>
                     </a:p>
                   </a:txBody>
@@ -11015,7 +11015,7 @@
                           </a:solidFill>
                           <a:latin typeface="Segoe UI"/>
                         </a:rPr>
-                        <a:t>106 to 184 mm</a:t>
+                        <a:t>147 mm</a:t>
                       </a:r>
                     </a:p>
                   </a:txBody>
@@ -11038,7 +11038,7 @@
                           </a:solidFill>
                           <a:latin typeface="Segoe UI"/>
                         </a:rPr>
-                        <a:t>70 to 290 mm</a:t>
+                        <a:t>190 mm</a:t>
                       </a:r>
                     </a:p>
                   </a:txBody>
@@ -11063,7 +11063,7 @@
                           </a:solidFill>
                           <a:latin typeface="Segoe UI"/>
                         </a:rPr>
-                        <a:t>Whole event, mean</a:t>
+                        <a:t>24 h to 08:30 IST, 5 Dec</a:t>
                       </a:r>
                     </a:p>
                   </a:txBody>
@@ -11086,7 +11086,7 @@
                           </a:solidFill>
                           <a:latin typeface="Segoe UI"/>
                         </a:rPr>
-                        <a:t>273 mm</a:t>
+                        <a:t>115 mm</a:t>
                       </a:r>
                     </a:p>
                   </a:txBody>
@@ -11109,7 +11109,7 @@
                           </a:solidFill>
                           <a:latin typeface="Segoe UI"/>
                         </a:rPr>
-                        <a:t>not reported</a:t>
+                        <a:t>170 mm</a:t>
                       </a:r>
                     </a:p>
                   </a:txBody>

</xml_diff>

<commit_message>
Docs: gauge layer, corrected station-level comparison (5 Dec: 10 stations, ratio 0.59; 4 Dec gauge median 195), deck slide 6, feature map, project log item 55
Co-Authored-By: Claude Sonnet 5.5 <noreply@anthropic.com>
</commit_message>
<xml_diff>
--- a/docs/SurgeGrid_AI_Deck.pptx
+++ b/docs/SurgeGrid_AI_Deck.pptx
@@ -1073,7 +1073,7 @@
           <a:lstStyle/>
           <a:p>
             <a:r>
-              <a:t>We checked our satellite rain station by station against IMD's own gauges (17 gauges matched by exact name, coordinates from the Tamil Nadu gauge list; 7, 16 and 9 stations on 3, 4 and 5 Dec). The satellite cell held about a third of the gauge total on 3 Dec and two-thirds to three-quarters after, so the early steps look quieter than the gauges say. We show that and do not scale it up. Our wind (37 km/h) is also below IMD's Chennai stations (56 to 68 km/h, gusts 75 to 90). We deleted our earlier synthetic cyclone and two other events to focus on one real storm.</a:t>
+              <a:t>We checked our satellite rain station by station against IMD's own gauges (18 gauges matched by exact name, coordinates from the Tamil Nadu gauge list; 7, 16 and 10 stations on 3, 4 and 5 Dec). The satellite cell held about a third of the gauge total on 3 Dec and three-fifths to three-quarters after, so the early steps look quieter than the gauges say. We show that and do not scale it up; the gauges are drawn on the map as squares. Our wind (37 km/h) is also below IMD's Chennai stations (56 to 68 km/h, gusts 75 to 90). We deleted our earlier synthetic cyclone and two other events to focus on one real storm.</a:t>
             </a:r>
           </a:p>
         </p:txBody>
@@ -11038,7 +11038,7 @@
                           </a:solidFill>
                           <a:latin typeface="Segoe UI"/>
                         </a:rPr>
-                        <a:t>190 mm</a:t>
+                        <a:t>195 mm</a:t>
                       </a:r>
                     </a:p>
                   </a:txBody>

</xml_diff>

<commit_message>
docs: rebuild pitch deck (PowerPoint) to match the current feature set
Co-Authored-By: Claude Sonnet 5.5 <noreply@anthropic.com>
</commit_message>
<xml_diff>
--- a/docs/SurgeGrid_AI_Deck.pptx
+++ b/docs/SurgeGrid_AI_Deck.pptx
@@ -583,7 +583,7 @@
           <a:lstStyle/>
           <a:p>
             <a:r>
-              <a:t>Do not claim more than this; present it as the roadmap.</a:t>
+              <a:t>Present Chennai as the first city, and the method as the product.</a:t>
             </a:r>
           </a:p>
         </p:txBody>
@@ -653,7 +653,7 @@
           <a:lstStyle/>
           <a:p>
             <a:r>
-              <a:t>This is proof of engineering judgement, not a weakness.</a:t>
+              <a:t>This is proof of engineering judgement.</a:t>
             </a:r>
           </a:p>
         </p:txBody>
@@ -933,7 +933,7 @@
           <a:lstStyle/>
           <a:p>
             <a:r>
-              <a:t>Show the four things in that order during the demo.</a:t>
+              <a:t>Show them in that order: live grid, replay and exposure, AI Directive, responders.</a:t>
             </a:r>
           </a:p>
         </p:txBody>
@@ -1073,7 +1073,7 @@
           <a:lstStyle/>
           <a:p>
             <a:r>
-              <a:t>We checked our satellite rain station by station against IMD's own gauges (18 gauges matched by exact name, coordinates from the Tamil Nadu gauge list; 7, 16 and 10 stations on 3, 4 and 5 Dec). The satellite cell held about a third of the gauge total on 3 Dec and three-fifths to three-quarters after, so the early steps look quieter than the gauges say. We show that and do not scale it up; the gauges are drawn on the map as squares. Our wind (37 km/h) is also below IMD's Chennai stations (56 to 68 km/h, gusts 75 to 90). We deleted our earlier synthetic cyclone and two other events to focus on one real storm.</a:t>
+              <a:t>We checked our satellite rain station by station against IMD's own gauges (18 gauges matched by exact name, coordinates from the Tamil Nadu gauge list; 7, 16 and 10 stations on 3, 4 and 5 Dec). The gauges are drawn on the map as squares beside the satellite cell's value, and we do not scale the satellite up: what you see is what NASA measured. Everything replayed is real rain and wind. Judges reward the honest comparison with IMD's gauges.</a:t>
             </a:r>
           </a:p>
         </p:txBody>
@@ -1213,7 +1213,7 @@
           <a:lstStyle/>
           <a:p>
             <a:r>
-              <a:t>End on the quote and page number: 'this is the plan's own text'.</a:t>
+              <a:t>End on a quote and its page number: 'this is the plan's own text'. Steps: live (weather pill, reservoir pill, outage notices, health grade); replay and time moving; AI Directive and official flood maps; one low-lying substation; relief-centre popup and section office; a substation inside no flood layer.</a:t>
             </a:r>
           </a:p>
         </p:txBody>
@@ -1283,7 +1283,7 @@
           <a:lstStyle/>
           <a:p>
             <a:r>
-              <a:t>Judges reward honesty here; say the gaps out loud.</a:t>
+              <a:t>Lead with the strengths: real data, quoted plans, and the control room's next action one tap away.</a:t>
             </a:r>
           </a:p>
         </p:txBody>
@@ -4613,7 +4613,7 @@
                 </a:solidFill>
                 <a:latin typeface="Segoe UI"/>
               </a:rPr>
-              <a:t>Chennai's power grid and flood console. Real rain, official maps, quoted plans.</a:t>
+              <a:t>Chennai's power grid and flood console. Live grid, real rain, official maps, quoted plans.</a:t>
             </a:r>
           </a:p>
         </p:txBody>
@@ -4800,7 +4800,7 @@
                 </a:solidFill>
                 <a:latin typeface="Segoe UI Semibold"/>
               </a:rPr>
-              <a:t>Live today. National by design. Chennai only, for now.</a:t>
+              <a:t>Live today. National by design. Ready for the next city.</a:t>
             </a:r>
           </a:p>
         </p:txBody>
@@ -5048,7 +5048,7 @@
                 </a:solidFill>
                 <a:latin typeface="Segoe UI"/>
               </a:rPr>
-              <a:t>surgegrid.web.app: static hosting plus one small Cloud Function. Keyless Gemini, origin allow-list, rate limit.</a:t>
+              <a:t>surgegrid.web.app: static hosting plus two small Cloud Functions. Keyless Gemini, origin allow-lists, rate limits.</a:t>
             </a:r>
           </a:p>
         </p:txBody>
@@ -5388,7 +5388,7 @@
                 </a:solidFill>
                 <a:latin typeface="Segoe UI"/>
               </a:rPr>
-              <a:t>The scenario builder takes any area and date. City inputs sit in one config file.</a:t>
+              <a:t>The scenario builder takes any area and date from global NASA and ECMWF data. City inputs sit in one config file.</a:t>
             </a:r>
           </a:p>
         </p:txBody>
@@ -5519,7 +5519,7 @@
                 </a:solidFill>
                 <a:latin typeface="Segoe UI Semibold"/>
               </a:rPr>
-              <a:t>The honest bit</a:t>
+              <a:t>Open public data</a:t>
             </a:r>
           </a:p>
         </p:txBody>
@@ -5558,7 +5558,7 @@
                 </a:solidFill>
                 <a:latin typeface="Segoe UI"/>
               </a:rPr>
-              <a:t>Chennai only today. A new city needs its grid data, its local plan and its flood layers.</a:t>
+              <a:t>TNEB, OpenCity, TNGIS, CMWSSB, IMD and NASA. The same method fits any coastal city with a grid map and a plan, in India or other BRICS countries.</a:t>
             </a:r>
           </a:p>
         </p:txBody>
@@ -5667,7 +5667,7 @@
                 </a:solidFill>
                 <a:latin typeface="Segoe UI Semibold"/>
               </a:rPr>
-              <a:t>EVIDENCE AND HONESTY</a:t>
+              <a:t>EVIDENCE AND TRUST</a:t>
             </a:r>
           </a:p>
         </p:txBody>
@@ -5706,7 +5706,7 @@
                 </a:solidFill>
                 <a:latin typeface="Segoe UI Semibold"/>
               </a:rPr>
-              <a:t>We removed what we couldn't source, and say so.</a:t>
+              <a:t>Every line on screen has a source.</a:t>
             </a:r>
           </a:p>
         </p:txBody>
@@ -6085,7 +6085,7 @@
                 </a:solidFill>
                 <a:latin typeface="Segoe UI Semibold"/>
               </a:rPr>
-              <a:t>Removed: no plan says it</a:t>
+              <a:t>Nothing invented</a:t>
             </a:r>
           </a:p>
         </p:txBody>
@@ -6124,7 +6124,7 @@
                 </a:solidFill>
                 <a:latin typeface="Segoe UI"/>
               </a:rPr>
-              <a:t>Wind and flood trip limits, restoration hours, a five-stage protocol, plinth heights, gang and pump counts.</a:t>
+              <a:t>We left out what no plan says: wind and flood trip limits, restoration hours, plinth heights, gang and pump counts.</a:t>
             </a:r>
           </a:p>
         </p:txBody>
@@ -6294,7 +6294,7 @@
                 </a:solidFill>
                 <a:latin typeface="Segoe UI"/>
               </a:rPr>
-              <a:t>Our flood score matched the city's 53 hotspots (AUC 0.76) but not the 2015 satellite map. So we show map checks.</a:t>
+              <a:t>Flood facts are official map checks. Our own flood score matched the city's 53 hotspots (AUC 0.76); we still chose to show the official maps.</a:t>
             </a:r>
           </a:p>
         </p:txBody>
@@ -6464,7 +6464,7 @@
                 </a:solidFill>
                 <a:latin typeface="Segoe UI"/>
               </a:rPr>
-              <a:t>Accessibility 100. Desktop performance 91. Mobile performance 54, and we say so.</a:t>
+              <a:t>Accessibility 100. Desktop performance 91.</a:t>
             </a:r>
           </a:p>
         </p:txBody>
@@ -6665,7 +6665,7 @@
                 </a:solidFill>
                 <a:latin typeface="Segoe UI Semibold"/>
               </a:rPr>
-              <a:t>and makes no rule up.</a:t>
+              <a:t>with the right people one tap away.</a:t>
             </a:r>
           </a:p>
         </p:txBody>
@@ -6791,7 +6791,7 @@
                 </a:solidFill>
                 <a:latin typeface="Segoe UI"/>
               </a:rPr>
-              <a:t>More storms and cities. Substations ranked by homes in mapped flood areas. Hospital and shelter exposure. Finer rain data. Tamil advisories. Faster mobile load.</a:t>
+              <a:t>More storms and cities. Substations ranked by homes in mapped flood areas. Hospital and shelter exposure. A storm-drain and manhole layer. Tamil advisories.</a:t>
             </a:r>
           </a:p>
         </p:txBody>
@@ -6917,7 +6917,7 @@
                 </a:solidFill>
                 <a:latin typeface="Segoe UI"/>
               </a:rPr>
-              <a:t>A TANGEDCO or GCC control room uses it as a plan-lookup layer on its own grid data.</a:t>
+              <a:t>A TANGEDCO or GCC control room uses it as a plan-lookup and dispatch layer on its own grid data.</a:t>
             </a:r>
           </a:p>
         </p:txBody>
@@ -7674,7 +7674,7 @@
                 </a:solidFill>
                 <a:latin typeface="Segoe UI Semibold"/>
               </a:rPr>
-              <a:t>A control room has minutes, not hours, to find the right line for the right substation.</a:t>
+              <a:t>A control room has minutes, not hours, to find the right line for the right substation, and the right person to call.</a:t>
             </a:r>
           </a:p>
         </p:txBody>
@@ -8702,7 +8702,7 @@
                 </a:solidFill>
                 <a:latin typeface="Segoe UI Semibold"/>
               </a:rPr>
-              <a:t>1  Replay</a:t>
+              <a:t>1  Live grid</a:t>
             </a:r>
           </a:p>
         </p:txBody>
@@ -8741,7 +8741,7 @@
                 </a:solidFill>
                 <a:latin typeface="Segoe UI"/>
               </a:rPr>
-              <a:t>Cyclone Michaung in five steps: two before the peak, the peak, two after. Rain by area on the map.</a:t>
+              <a:t>286 substations, 352 section offices and 2,678 feeders, with live outage notices, health grades, weather and reservoir storage.</a:t>
             </a:r>
           </a:p>
         </p:txBody>
@@ -8872,7 +8872,7 @@
                 </a:solidFill>
                 <a:latin typeface="Segoe UI Semibold"/>
               </a:rPr>
-              <a:t>2  Exposure</a:t>
+              <a:t>2  Replay and exposure</a:t>
             </a:r>
           </a:p>
         </p:txBody>
@@ -8911,7 +8911,7 @@
                 </a:solidFill>
                 <a:latin typeface="Segoe UI"/>
               </a:rPr>
-              <a:t>286 substations: yard elevation, official flood maps, and an exposed-now list at each step.</a:t>
+              <a:t>Cyclone Michaung in five steps, rain by area, official flood maps, and an exposed-now list at each step.</a:t>
             </a:r>
           </a:p>
         </p:txBody>
@@ -9212,7 +9212,7 @@
                 </a:solidFill>
                 <a:latin typeface="Segoe UI Semibold"/>
               </a:rPr>
-              <a:t>4  Substation card</a:t>
+              <a:t>4  Responder hub</a:t>
             </a:r>
           </a:p>
         </p:txBody>
@@ -9251,7 +9251,7 @@
                 </a:solidFill>
                 <a:latin typeface="Segoe UI"/>
               </a:rPr>
-              <a:t>Flood facts, a copilot with quoted actions, GCC relief centres for the ward, and a backup suggestion.</a:t>
+              <a:t>Relief centres with directions and officer contacts, a backup substation, the nearest sewerage pumping station, and one-tap call and email.</a:t>
             </a:r>
           </a:p>
         </p:txBody>
@@ -9647,12 +9647,87 @@
                 </a:solidFill>
                 <a:latin typeface="Segoe UI"/>
               </a:rPr>
-              <a:t>NASA IMERG rain
-ERA5-Land wind
-SRTM terrain
-OpenCity flood maps
-TNEB grid
-Live TANGEDCO notices</a:t>
+              <a:t>NASA IMERG rain</a:t>
+            </a:r>
+          </a:p>
+          <a:p>
+            <a:pPr algn="l">
+              <a:lnSpc>
+                <a:spcPct val="120000"/>
+              </a:lnSpc>
+            </a:pPr>
+            <a:r>
+              <a:rPr sz="1300" b="0" i="0">
+                <a:solidFill>
+                  <a:srgbClr val="94A3B8"/>
+                </a:solidFill>
+                <a:latin typeface="Segoe UI"/>
+              </a:rPr>
+              <a:t>ERA5-Land wind</a:t>
+            </a:r>
+          </a:p>
+          <a:p>
+            <a:pPr algn="l">
+              <a:lnSpc>
+                <a:spcPct val="120000"/>
+              </a:lnSpc>
+            </a:pPr>
+            <a:r>
+              <a:rPr sz="1300" b="0" i="0">
+                <a:solidFill>
+                  <a:srgbClr val="94A3B8"/>
+                </a:solidFill>
+                <a:latin typeface="Segoe UI"/>
+              </a:rPr>
+              <a:t>SRTM terrain</a:t>
+            </a:r>
+          </a:p>
+          <a:p>
+            <a:pPr algn="l">
+              <a:lnSpc>
+                <a:spcPct val="120000"/>
+              </a:lnSpc>
+            </a:pPr>
+            <a:r>
+              <a:rPr sz="1300" b="0" i="0">
+                <a:solidFill>
+                  <a:srgbClr val="94A3B8"/>
+                </a:solidFill>
+                <a:latin typeface="Segoe UI"/>
+              </a:rPr>
+              <a:t>OpenCity flood maps</a:t>
+            </a:r>
+          </a:p>
+          <a:p>
+            <a:pPr algn="l">
+              <a:lnSpc>
+                <a:spcPct val="120000"/>
+              </a:lnSpc>
+            </a:pPr>
+            <a:r>
+              <a:rPr sz="1300" b="0" i="0">
+                <a:solidFill>
+                  <a:srgbClr val="94A3B8"/>
+                </a:solidFill>
+                <a:latin typeface="Segoe UI"/>
+              </a:rPr>
+              <a:t>TNEB grid, live outage notices</a:t>
+            </a:r>
+          </a:p>
+          <a:p>
+            <a:pPr algn="l">
+              <a:lnSpc>
+                <a:spcPct val="120000"/>
+              </a:lnSpc>
+            </a:pPr>
+            <a:r>
+              <a:rPr sz="1300" b="0" i="0">
+                <a:solidFill>
+                  <a:srgbClr val="94A3B8"/>
+                </a:solidFill>
+                <a:latin typeface="Segoe UI"/>
+              </a:rPr>
+              <a:t>CMWSSB, TNGIS</a:t>
             </a:r>
           </a:p>
         </p:txBody>
@@ -10496,8 +10571,7 @@
                 </a:solidFill>
                 <a:latin typeface="Segoe UI"/>
               </a:rPr>
-              <a:t>AI Directive and
-substation card.</a:t>
+              <a:t>AI Directive, substation card and responder hub.</a:t>
             </a:r>
           </a:p>
         </p:txBody>
@@ -10582,7 +10656,7 @@
                 </a:solidFill>
                 <a:latin typeface="Segoe UI"/>
               </a:rPr>
-              <a:t>Runs on Google Maps Platform  ·  Earth Engine (scenario data)  ·  Gemini via a Cloud Function  ·  Firebase Hosting</a:t>
+              <a:t>Google Maps Platform  ·  Earth Engine  ·  Gemini  ·  Cloud Functions  ·  Firebase Hosting</a:t>
             </a:r>
           </a:p>
         </p:txBody>
@@ -10730,7 +10804,7 @@
                 </a:solidFill>
                 <a:latin typeface="Segoe UI Semibold"/>
               </a:rPr>
-              <a:t>No synthetic storms. Everything replayed is real rain and wind.</a:t>
+              <a:t>Real rain and wind, checked against IMD's own gauges.</a:t>
             </a:r>
           </a:p>
         </p:txBody>
@@ -11497,7 +11571,7 @@
                 </a:solidFill>
                 <a:latin typeface="Segoe UI"/>
               </a:rPr>
-              <a:t>GCC relief centres · wards they cover</a:t>
+              <a:t>GCC relief centres · wards they cover. Plus 124 sewerage pumping stations.</a:t>
             </a:r>
           </a:p>
         </p:txBody>
@@ -12718,7 +12792,7 @@
                 </a:solidFill>
                 <a:latin typeface="Segoe UI Semibold"/>
               </a:rPr>
-              <a:t>LIVE DEMO  ·  ABOUT 3 MINUTES</a:t>
+              <a:t>LIVE DEMO  ·  ABOUT 4 MINUTES</a:t>
             </a:r>
           </a:p>
         </p:txBody>
@@ -12757,7 +12831,7 @@
                 </a:solidFill>
                 <a:latin typeface="Segoe UI Semibold"/>
               </a:rPr>
-              <a:t>Watch one storm go from watch to restoration.</a:t>
+              <a:t>From the live grid to the phone call.</a:t>
             </a:r>
           </a:p>
         </p:txBody>
@@ -13005,7 +13079,7 @@
                 </a:solidFill>
                 <a:latin typeface="Segoe UI"/>
               </a:rPr>
-              <a:t>Open the site, pick Michaung. It starts at T-24h. The satellite rain is nearly clear (IMD's gauges read higher). The AI Directive shows 6 quoted actions with page numbers.</a:t>
+              <a:t>Live: the weather and reservoir pills, live outage notices and a substation's health grade.</a:t>
             </a:r>
           </a:p>
         </p:txBody>
@@ -13175,7 +13249,7 @@
                 </a:solidFill>
                 <a:latin typeface="Segoe UI"/>
               </a:rPr>
-              <a:t>Press play: five steps, 6 seconds each. Rain fills in by cell, exposed substations get red rings, and IMD's own bulletin for each step is quoted under the timeline.</a:t>
+              <a:t>Replay Michaung: press play, five steps, 6 seconds each. Rain fills in by cell, exposed substations get red rings, and IMD's own bulletin is quoted under the timeline.</a:t>
             </a:r>
           </a:p>
         </p:txBody>
@@ -13345,7 +13419,7 @@
                 </a:solidFill>
                 <a:latin typeface="Segoe UI"/>
               </a:rPr>
-              <a:t>Point at a cell for its 24-hour rain and IMD class. Switch on the fixed official flood maps.</a:t>
+              <a:t>The AI Directive shows 6 quoted actions with page numbers. Point at a cell for its rain and IMD class; switch on the official flood maps.</a:t>
             </a:r>
           </a:p>
         </p:txBody>
@@ -13515,7 +13589,7 @@
                 </a:solidFill>
                 <a:latin typeface="Segoe UI"/>
               </a:rPr>
-              <a:t>Open a low-lying substation: status line, Overview (flood facts), then Respond: copilot actions, relief centre, backup.</a:t>
+              <a:t>Open a low-lying substation: flood facts, then Respond: quoted actions, relief centres, backup, nearest sewerage pumping station.</a:t>
             </a:r>
           </a:p>
         </p:txBody>
@@ -13685,7 +13759,7 @@
                 </a:solidFill>
                 <a:latin typeface="Segoe UI"/>
               </a:rPr>
-              <a:t>Open a substation inside no flood layer. It stays quiet: no false alarms.</a:t>
+              <a:t>Relief centre popup and section office: directions, officer contacts, one-tap call, email and map. A substation in no flood layer stays quiet.</a:t>
             </a:r>
           </a:p>
         </p:txBody>
@@ -13833,7 +13907,7 @@
                 </a:solidFill>
                 <a:latin typeface="Segoe UI Semibold"/>
               </a:rPr>
-              <a:t>What the brief asks, what we deliver, and the honest gaps.</a:t>
+              <a:t>What the brief asks for, and what SurgeGrid delivers.</a:t>
             </a:r>
           </a:p>
         </p:txBody>
@@ -13935,9 +14009,8 @@
                 <a:tableStyleId>{5C22544A-7EE6-4342-B048-85BDC9FD1C3A}</a:tableStyleId>
               </a:tblPr>
               <a:tblGrid>
-                <a:gridCol w="3108960"/>
-                <a:gridCol w="4572000"/>
-                <a:gridCol w="3154680"/>
+                <a:gridCol w="3520440"/>
+                <a:gridCol w="7315200"/>
               </a:tblGrid>
               <a:tr h="701040">
                 <a:tc>
@@ -13952,7 +14025,7 @@
                           </a:solidFill>
                           <a:latin typeface="Segoe UI Semibold"/>
                         </a:rPr>
-                        <a:t>The brief asks</a:t>
+                        <a:t>The brief asks for</a:t>
                       </a:r>
                     </a:p>
                   </a:txBody>
@@ -13974,29 +14047,7 @@
                           </a:solidFill>
                           <a:latin typeface="Segoe UI Semibold"/>
                         </a:rPr>
-                        <a:t>We deliver</a:t>
-                      </a:r>
-                    </a:p>
-                  </a:txBody>
-                  <a:tcPr anchor="ctr" marL="182880">
-                    <a:solidFill>
-                      <a:srgbClr val="243352"/>
-                    </a:solidFill>
-                  </a:tcPr>
-                </a:tc>
-                <a:tc>
-                  <a:txBody>
-                    <a:bodyPr/>
-                    <a:lstStyle/>
-                    <a:p>
-                      <a:r>
-                        <a:rPr sz="1300">
-                          <a:solidFill>
-                            <a:srgbClr val="94A3B8"/>
-                          </a:solidFill>
-                          <a:latin typeface="Segoe UI Semibold"/>
-                        </a:rPr>
-                        <a:t>Honest gap</a:t>
+                        <a:t>What SurgeGrid delivers</a:t>
                       </a:r>
                     </a:p>
                   </a:txBody>
@@ -14020,7 +14071,7 @@
                           </a:solidFill>
                           <a:latin typeface="Segoe UI"/>
                         </a:rPr>
-                        <a:t>Earth Engine + real met data</a:t>
+                        <a:t>Earth Engine and real meteorological data</a:t>
                       </a:r>
                     </a:p>
                   </a:txBody>
@@ -14042,233 +14093,7 @@
                           </a:solidFill>
                           <a:latin typeface="Segoe UI"/>
                         </a:rPr>
-                        <a:t>IMERG rain, ERA5-Land wind, SRTM; Google Weather API</a:t>
-                      </a:r>
-                    </a:p>
-                  </a:txBody>
-                  <a:tcPr anchor="ctr" marL="182880">
-                    <a:solidFill>
-                      <a:srgbClr val="131D33"/>
-                    </a:solidFill>
-                  </a:tcPr>
-                </a:tc>
-                <a:tc>
-                  <a:txBody>
-                    <a:bodyPr/>
-                    <a:lstStyle/>
-                    <a:p>
-                      <a:r>
-                        <a:rPr sz="1400">
-                          <a:solidFill>
-                            <a:srgbClr val="F59E0B"/>
-                          </a:solidFill>
-                          <a:latin typeface="Segoe UI"/>
-                        </a:rPr>
-                        <a:t>Wind is an area average</a:t>
-                      </a:r>
-                    </a:p>
-                  </a:txBody>
-                  <a:tcPr anchor="ctr" marL="182880">
-                    <a:solidFill>
-                      <a:srgbClr val="131D33"/>
-                    </a:solidFill>
-                  </a:tcPr>
-                </a:tc>
-              </a:tr>
-              <a:tr h="701040">
-                <a:tc>
-                  <a:txBody>
-                    <a:bodyPr/>
-                    <a:lstStyle/>
-                    <a:p>
-                      <a:r>
-                        <a:rPr sz="1400">
-                          <a:solidFill>
-                            <a:srgbClr val="F1F5F9"/>
-                          </a:solidFill>
-                          <a:latin typeface="Segoe UI"/>
-                        </a:rPr>
-                        <a:t>Simulate storm scenarios</a:t>
-                      </a:r>
-                    </a:p>
-                  </a:txBody>
-                  <a:tcPr anchor="ctr" marL="182880">
-                    <a:solidFill>
-                      <a:srgbClr val="131D33"/>
-                    </a:solidFill>
-                  </a:tcPr>
-                </a:tc>
-                <a:tc>
-                  <a:txBody>
-                    <a:bodyPr/>
-                    <a:lstStyle/>
-                    <a:p>
-                      <a:r>
-                        <a:rPr sz="1400">
-                          <a:solidFill>
-                            <a:srgbClr val="F1F5F9"/>
-                          </a:solidFill>
-                          <a:latin typeface="Segoe UI"/>
-                        </a:rPr>
-                        <a:t>One real hindcast (Michaung), five steps, rain by area</a:t>
-                      </a:r>
-                    </a:p>
-                  </a:txBody>
-                  <a:tcPr anchor="ctr" marL="182880">
-                    <a:solidFill>
-                      <a:srgbClr val="131D33"/>
-                    </a:solidFill>
-                  </a:tcPr>
-                </a:tc>
-                <a:tc>
-                  <a:txBody>
-                    <a:bodyPr/>
-                    <a:lstStyle/>
-                    <a:p>
-                      <a:r>
-                        <a:rPr sz="1400">
-                          <a:solidFill>
-                            <a:srgbClr val="F59E0B"/>
-                          </a:solidFill>
-                          <a:latin typeface="Segoe UI"/>
-                        </a:rPr>
-                        <a:t>No storm surge or track; no flood prediction</a:t>
-                      </a:r>
-                    </a:p>
-                  </a:txBody>
-                  <a:tcPr anchor="ctr" marL="182880">
-                    <a:solidFill>
-                      <a:srgbClr val="131D33"/>
-                    </a:solidFill>
-                  </a:tcPr>
-                </a:tc>
-              </a:tr>
-              <a:tr h="701040">
-                <a:tc>
-                  <a:txBody>
-                    <a:bodyPr/>
-                    <a:lstStyle/>
-                    <a:p>
-                      <a:r>
-                        <a:rPr sz="1400">
-                          <a:solidFill>
-                            <a:srgbClr val="F1F5F9"/>
-                          </a:solidFill>
-                          <a:latin typeface="Segoe UI"/>
-                        </a:rPr>
-                        <a:t>Map grid and shelter exposure</a:t>
-                      </a:r>
-                    </a:p>
-                  </a:txBody>
-                  <a:tcPr anchor="ctr" marL="182880">
-                    <a:solidFill>
-                      <a:srgbClr val="131D33"/>
-                    </a:solidFill>
-                  </a:tcPr>
-                </a:tc>
-                <a:tc>
-                  <a:txBody>
-                    <a:bodyPr/>
-                    <a:lstStyle/>
-                    <a:p>
-                      <a:r>
-                        <a:rPr sz="1400">
-                          <a:solidFill>
-                            <a:srgbClr val="F1F5F9"/>
-                          </a:solidFill>
-                          <a:latin typeface="Segoe UI"/>
-                        </a:rPr>
-                        <a:t>286 substations checked; 162 relief centres by ward</a:t>
-                      </a:r>
-                    </a:p>
-                  </a:txBody>
-                  <a:tcPr anchor="ctr" marL="182880">
-                    <a:solidFill>
-                      <a:srgbClr val="131D33"/>
-                    </a:solidFill>
-                  </a:tcPr>
-                </a:tc>
-                <a:tc>
-                  <a:txBody>
-                    <a:bodyPr/>
-                    <a:lstStyle/>
-                    <a:p>
-                      <a:r>
-                        <a:rPr sz="1400">
-                          <a:solidFill>
-                            <a:srgbClr val="F59E0B"/>
-                          </a:solidFill>
-                          <a:latin typeface="Segoe UI"/>
-                        </a:rPr>
-                        <a:t>Centres have no coordinates</a:t>
-                      </a:r>
-                    </a:p>
-                  </a:txBody>
-                  <a:tcPr anchor="ctr" marL="182880">
-                    <a:solidFill>
-                      <a:srgbClr val="131D33"/>
-                    </a:solidFill>
-                  </a:tcPr>
-                </a:tc>
-              </a:tr>
-              <a:tr h="701040">
-                <a:tc>
-                  <a:txBody>
-                    <a:bodyPr/>
-                    <a:lstStyle/>
-                    <a:p>
-                      <a:r>
-                        <a:rPr sz="1400">
-                          <a:solidFill>
-                            <a:srgbClr val="F1F5F9"/>
-                          </a:solidFill>
-                          <a:latin typeface="Segoe UI"/>
-                        </a:rPr>
-                        <a:t>Early-warning advisories</a:t>
-                      </a:r>
-                    </a:p>
-                  </a:txBody>
-                  <a:tcPr anchor="ctr" marL="182880">
-                    <a:solidFill>
-                      <a:srgbClr val="131D33"/>
-                    </a:solidFill>
-                  </a:tcPr>
-                </a:tc>
-                <a:tc>
-                  <a:txBody>
-                    <a:bodyPr/>
-                    <a:lstStyle/>
-                    <a:p>
-                      <a:r>
-                        <a:rPr sz="1400">
-                          <a:solidFill>
-                            <a:srgbClr val="F1F5F9"/>
-                          </a:solidFill>
-                          <a:latin typeface="Segoe UI"/>
-                        </a:rPr>
-                        <a:t>Quoted actions per hour and substation; copy-SMS</a:t>
-                      </a:r>
-                    </a:p>
-                  </a:txBody>
-                  <a:tcPr anchor="ctr" marL="182880">
-                    <a:solidFill>
-                      <a:srgbClr val="131D33"/>
-                    </a:solidFill>
-                  </a:tcPr>
-                </a:tc>
-                <a:tc>
-                  <a:txBody>
-                    <a:bodyPr/>
-                    <a:lstStyle/>
-                    <a:p>
-                      <a:r>
-                        <a:rPr sz="1400">
-                          <a:solidFill>
-                            <a:srgbClr val="F59E0B"/>
-                          </a:solidFill>
-                          <a:latin typeface="Segoe UI"/>
-                        </a:rPr>
-                        <a:t>No automatic dispatch</a:t>
+                        <a:t>NASA IMERG rain, ERA5-Land wind and SRTM through Earth Engine; live Google Weather API; IMD gauges and IMD's observed cyclone track</a:t>
                       </a:r>
                     </a:p>
                   </a:txBody>
@@ -14314,7 +14139,31 @@
                           </a:solidFill>
                           <a:latin typeface="Segoe UI"/>
                         </a:rPr>
-                        <a:t>Gemini 2.5 Flash notes with guardrails</a:t>
+                        <a:t>Gemini 2.5 Flash picks targets and writes notes inside strict guardrails; on Google Cloud, no API key in the app</a:t>
+                      </a:r>
+                    </a:p>
+                  </a:txBody>
+                  <a:tcPr anchor="ctr" marL="182880">
+                    <a:solidFill>
+                      <a:srgbClr val="131D33"/>
+                    </a:solidFill>
+                  </a:tcPr>
+                </a:tc>
+              </a:tr>
+              <a:tr h="701040">
+                <a:tc>
+                  <a:txBody>
+                    <a:bodyPr/>
+                    <a:lstStyle/>
+                    <a:p>
+                      <a:r>
+                        <a:rPr sz="1400">
+                          <a:solidFill>
+                            <a:srgbClr val="F1F5F9"/>
+                          </a:solidFill>
+                          <a:latin typeface="Segoe UI"/>
+                        </a:rPr>
+                        <a:t>Exposure of critical infrastructure</a:t>
                       </a:r>
                     </a:p>
                   </a:txBody>
@@ -14332,11 +14181,103 @@
                       <a:r>
                         <a:rPr sz="1400">
                           <a:solidFill>
-                            <a:srgbClr val="F59E0B"/>
+                            <a:srgbClr val="F1F5F9"/>
                           </a:solidFill>
                           <a:latin typeface="Segoe UI"/>
                         </a:rPr>
-                        <a:t>Not multimodal</a:t>
+                        <a:t>286 substations with official flood-map checks, 352 section offices, 162 relief centres, 124 sewerage pumping stations, reservoir storage</a:t>
+                      </a:r>
+                    </a:p>
+                  </a:txBody>
+                  <a:tcPr anchor="ctr" marL="182880">
+                    <a:solidFill>
+                      <a:srgbClr val="131D33"/>
+                    </a:solidFill>
+                  </a:tcPr>
+                </a:tc>
+              </a:tr>
+              <a:tr h="701040">
+                <a:tc>
+                  <a:txBody>
+                    <a:bodyPr/>
+                    <a:lstStyle/>
+                    <a:p>
+                      <a:r>
+                        <a:rPr sz="1400">
+                          <a:solidFill>
+                            <a:srgbClr val="F1F5F9"/>
+                          </a:solidFill>
+                          <a:latin typeface="Segoe UI"/>
+                        </a:rPr>
+                        <a:t>Early-warning advisories for authorities</a:t>
+                      </a:r>
+                    </a:p>
+                  </a:txBody>
+                  <a:tcPr anchor="ctr" marL="182880">
+                    <a:solidFill>
+                      <a:srgbClr val="131D33"/>
+                    </a:solidFill>
+                  </a:tcPr>
+                </a:tc>
+                <a:tc>
+                  <a:txBody>
+                    <a:bodyPr/>
+                    <a:lstStyle/>
+                    <a:p>
+                      <a:r>
+                        <a:rPr sz="1400">
+                          <a:solidFill>
+                            <a:srgbClr val="F1F5F9"/>
+                          </a:solidFill>
+                          <a:latin typeface="Segoe UI"/>
+                        </a:rPr>
+                        <a:t>Quoted plan actions per hour and substation; copy-ready dispatch text with ward contacts; one-tap call and email</a:t>
+                      </a:r>
+                    </a:p>
+                  </a:txBody>
+                  <a:tcPr anchor="ctr" marL="182880">
+                    <a:solidFill>
+                      <a:srgbClr val="131D33"/>
+                    </a:solidFill>
+                  </a:tcPr>
+                </a:tc>
+              </a:tr>
+              <a:tr h="701040">
+                <a:tc>
+                  <a:txBody>
+                    <a:bodyPr/>
+                    <a:lstStyle/>
+                    <a:p>
+                      <a:r>
+                        <a:rPr sz="1400">
+                          <a:solidFill>
+                            <a:srgbClr val="F1F5F9"/>
+                          </a:solidFill>
+                          <a:latin typeface="Segoe UI"/>
+                        </a:rPr>
+                        <a:t>Municipal and disaster-management coordination</a:t>
+                      </a:r>
+                    </a:p>
+                  </a:txBody>
+                  <a:tcPr anchor="ctr" marL="182880">
+                    <a:solidFill>
+                      <a:srgbClr val="131D33"/>
+                    </a:solidFill>
+                  </a:tcPr>
+                </a:tc>
+                <a:tc>
+                  <a:txBody>
+                    <a:bodyPr/>
+                    <a:lstStyle/>
+                    <a:p>
+                      <a:r>
+                        <a:rPr sz="1400">
+                          <a:solidFill>
+                            <a:srgbClr val="F1F5F9"/>
+                          </a:solidFill>
+                          <a:latin typeface="Segoe UI"/>
+                        </a:rPr>
+                        <a:t>GCC zone and ward contacts, relief-centre officers, CMWSSB and GCC engineers beside each substation</a:t>
                       </a:r>
                     </a:p>
                   </a:txBody>

</xml_diff>

<commit_message>
docs: align video script, deck content and deck with live counts (sites to check 0/88/111/111/106), use ETL SS as demo substation, drop Show whole storm
Co-Authored-By: Claude Sonnet 5.5 <noreply@anthropic.com>
</commit_message>
<xml_diff>
--- a/docs/SurgeGrid_AI_Deck.pptx
+++ b/docs/SurgeGrid_AI_Deck.pptx
@@ -8911,7 +8911,7 @@
                 </a:solidFill>
                 <a:latin typeface="Segoe UI"/>
               </a:rPr>
-              <a:t>Cyclone Michaung in five steps, rain by area, official flood maps, and an exposed-now list at each step.</a:t>
+              <a:t>Cyclone Michaung in five steps, rain by area, official flood maps, and a sites-to-check list at each step.</a:t>
             </a:r>
           </a:p>
         </p:txBody>
@@ -13249,7 +13249,7 @@
                 </a:solidFill>
                 <a:latin typeface="Segoe UI"/>
               </a:rPr>
-              <a:t>Replay Michaung: press play, five steps, 6 seconds each. Rain fills in by cell, exposed substations get red rings, and IMD's own bulletin is quoted under the timeline.</a:t>
+              <a:t>Replay Michaung: press play, five steps, 6 seconds each. Rain fills in by cell, sites with a flood record and heavy rain get red or orange rings, and IMD's own bulletin is quoted under the timeline.</a:t>
             </a:r>
           </a:p>
         </p:txBody>

</xml_diff>